<commit_message>
Add ROUGE comparison pipeline, results, and Results tab in web app
- Add 4-method ROUGE comparison pipeline (M1 extractive, M2 abstractive,
  M3 keyword-split, M4 BERT-ABSA-split) on SPACE + HASOS with pyrouge
  scripts and per-method reports.
- Add combined ROUGE comparison report (md + json) and
  space_hasos_final_consolidated.pptx.
- Drop legacy stage_io + e20_report pptx in favor of consolidated deck.
- Track the full web/ Next.js app: Explore (hotel aspect tree), Analyze
  (live paste-and-run), and the new Results tab (ROUGE comparison
  viewer with dataset/split switcher, macro table, per-aspect bar
  chart, method descriptions).
- Backend README stub for the FastAPI analyze service.
</commit_message>
<xml_diff>
--- a/outputs/space_hasos_full_e20_ranked_report.pptx
+++ b/outputs/space_hasos_full_e20_ranked_report.pptx
@@ -2,7 +2,7 @@
 <file path=ppt/presentation.xml><?xml version="1.0" encoding="utf-8"?>
 <p:presentation xmlns:a="http://schemas.openxmlformats.org/drawingml/2006/main" xmlns:r="http://schemas.openxmlformats.org/officeDocument/2006/relationships" xmlns:p="http://schemas.openxmlformats.org/presentationml/2006/main">
   <p:sldMasterIdLst>
-    <p:sldMasterId id="2147483648" r:id="rId11"/>
+    <p:sldMasterId id="2147483648" r:id="rId12"/>
   </p:sldMasterIdLst>
   <p:sldIdLst>
     <p:sldId id="256" r:id="rId1"/>
@@ -15,6 +15,7 @@
     <p:sldId id="263" r:id="rId8"/>
     <p:sldId id="264" r:id="rId9"/>
     <p:sldId id="265" r:id="rId10"/>
+    <p:sldId id="266" r:id="rId11"/>
   </p:sldIdLst>
   <p:sldSz cx="12192000" cy="6858000" type="wide"/>
   <p:notesSz cx="6858000" cy="9144000"/>
@@ -302,7 +303,7 @@
                   <a:srgbClr val="14213D"/>
                 </a:solidFill>
               </a:rPr>
-              <a:t>Synthesis rows: 1370</a:t>
+              <a:t>Synthesis rows: 0</a:t>
             </a:r>
             <a:endParaRPr lang="vi-VN" sz="1200"/>
           </a:p>
@@ -409,6 +410,253 @@
                   <a:srgbClr val="2563EB"/>
                 </a:solidFill>
               </a:rPr>
+              <a:t>QUALITY</a:t>
+            </a:r>
+            <a:endParaRPr lang="vi-VN" sz="800"/>
+          </a:p>
+        </p:txBody>
+      </p:sp>
+      <p:sp>
+        <p:nvSpPr>
+          <p:cNvPr id="3" name="Text 3"/>
+          <p:cNvSpPr txBox="1"/>
+          <p:nvPr/>
+        </p:nvSpPr>
+        <p:spPr>
+          <a:xfrm>
+            <a:off x="502920" y="512064"/>
+            <a:ext cx="10972800" cy="457200"/>
+          </a:xfrm>
+          <a:prstGeom prst="rect">
+            <a:avLst/>
+          </a:prstGeom>
+          <a:noFill/>
+          <a:ln>
+            <a:noFill/>
+          </a:ln>
+        </p:spPr>
+        <p:txBody>
+          <a:bodyPr wrap="square" lIns="91440" tIns="45720" rIns="91440" bIns="45720"/>
+          <a:lstStyle/>
+          <a:p>
+            <a:r>
+              <a:rPr lang="vi-VN" sz="2300" dirty="0">
+                <a:b/>
+                <a:solidFill>
+                  <a:srgbClr val="14213D"/>
+                </a:solidFill>
+              </a:rPr>
+              <a:t>Metrics và health checks</a:t>
+            </a:r>
+            <a:endParaRPr lang="vi-VN" sz="2300"/>
+          </a:p>
+        </p:txBody>
+      </p:sp>
+      <p:cxnSp>
+        <p:nvCxnSpPr>
+          <p:cNvPr id="4" name="Line 4"/>
+          <p:cNvCxnSpPr/>
+          <p:nvPr/>
+        </p:nvCxnSpPr>
+        <p:spPr>
+          <a:xfrm>
+            <a:off x="502920" y="1033271"/>
+            <a:ext cx="11155680" cy="0"/>
+          </a:xfrm>
+          <a:prstGeom prst="line">
+            <a:avLst/>
+          </a:prstGeom>
+          <a:ln w="12700">
+            <a:solidFill>
+              <a:srgbClr val="D8DEE9"/>
+            </a:solidFill>
+          </a:ln>
+        </p:spPr>
+      </p:cxnSp>
+      <p:sp>
+        <p:nvSpPr>
+          <p:cNvPr id="5" name="Text 5"/>
+          <p:cNvSpPr txBox="1"/>
+          <p:nvPr/>
+        </p:nvSpPr>
+        <p:spPr>
+          <a:xfrm>
+            <a:off x="777240" y="1325880"/>
+            <a:ext cx="4709160" cy="2057400"/>
+          </a:xfrm>
+          <a:prstGeom prst="rect">
+            <a:avLst/>
+          </a:prstGeom>
+          <a:solidFill>
+            <a:srgbClr val="FFFFFF"/>
+          </a:solidFill>
+          <a:ln w="9525">
+            <a:solidFill>
+              <a:srgbClr val="D8DEE9"/>
+            </a:solidFill>
+          </a:ln>
+        </p:spPr>
+        <p:txBody>
+          <a:bodyPr wrap="square" lIns="91440" tIns="45720" rIns="91440" bIns="45720"/>
+          <a:lstStyle/>
+          <a:p>
+            <a:r>
+              <a:rPr lang="vi-VN" sz="1250" dirty="0">
+                <a:solidFill>
+                  <a:srgbClr val="14213D"/>
+                </a:solidFill>
+              </a:rPr>
+              <a:t>source_fidelity: n/a</a:t>
+            </a:r>
+            <a:endParaRPr lang="vi-VN" sz="1250"/>
+          </a:p>
+          <a:p>
+            <a:r>
+              <a:rPr lang="vi-VN" sz="1250" dirty="0">
+                <a:solidFill>
+                  <a:srgbClr val="14213D"/>
+                </a:solidFill>
+              </a:rPr>
+              <a:t>source_fidelity_excl_truncated: n/a</a:t>
+            </a:r>
+            <a:endParaRPr lang="vi-VN" sz="1250"/>
+          </a:p>
+          <a:p>
+            <a:r>
+              <a:rPr lang="vi-VN" sz="1250" dirty="0">
+                <a:solidFill>
+                  <a:srgbClr val="14213D"/>
+                </a:solidFill>
+              </a:rPr>
+              <a:t>aspect_purity: n/a</a:t>
+            </a:r>
+            <a:endParaRPr lang="vi-VN" sz="1250"/>
+          </a:p>
+          <a:p>
+            <a:r>
+              <a:rPr lang="vi-VN" sz="1250" dirty="0">
+                <a:solidFill>
+                  <a:srgbClr val="14213D"/>
+                </a:solidFill>
+              </a:rPr>
+              <a:t>distinct_2: n/a</a:t>
+            </a:r>
+            <a:endParaRPr lang="vi-VN" sz="1250"/>
+          </a:p>
+          <a:p>
+            <a:r>
+              <a:rPr lang="vi-VN" sz="1250" dirty="0">
+                <a:solidFill>
+                  <a:srgbClr val="14213D"/>
+                </a:solidFill>
+              </a:rPr>
+              <a:t>self_bleu4: n/a</a:t>
+            </a:r>
+            <a:endParaRPr lang="vi-VN" sz="1250"/>
+          </a:p>
+        </p:txBody>
+      </p:sp>
+      <p:sp>
+        <p:nvSpPr>
+          <p:cNvPr id="6" name="Text 6"/>
+          <p:cNvSpPr txBox="1"/>
+          <p:nvPr/>
+        </p:nvSpPr>
+        <p:spPr>
+          <a:xfrm>
+            <a:off x="5577840" y="1325880"/>
+            <a:ext cx="5486400" cy="1143000"/>
+          </a:xfrm>
+          <a:prstGeom prst="rect">
+            <a:avLst/>
+          </a:prstGeom>
+          <a:solidFill>
+            <a:srgbClr val="FFFFFF"/>
+          </a:solidFill>
+          <a:ln w="9525">
+            <a:solidFill>
+              <a:srgbClr val="D8DEE9"/>
+            </a:solidFill>
+          </a:ln>
+        </p:spPr>
+        <p:txBody>
+          <a:bodyPr wrap="square" lIns="91440" tIns="45720" rIns="91440" bIns="45720"/>
+          <a:lstStyle/>
+          <a:p>
+            <a:r>
+              <a:rPr lang="vi-VN" sz="1250" dirty="0">
+                <a:solidFill>
+                  <a:srgbClr val="14213D"/>
+                </a:solidFill>
+              </a:rPr>
+              <a:t>HASOS không có gold summary nên dùng reference-free metrics: fidelity, purity, diversity, compression. BERTScore có thể chạy thêm nếu dependency/model tải được.</a:t>
+            </a:r>
+            <a:endParaRPr lang="vi-VN" sz="1250"/>
+          </a:p>
+        </p:txBody>
+      </p:sp>
+    </p:spTree>
+  </p:cSld>
+  <p:clrMapOvr>
+    <a:masterClrMapping/>
+  </p:clrMapOvr>
+</p:sld>
+</file>
+
+<file path=ppt/slides/slide11.xml><?xml version="1.0" encoding="utf-8"?>
+<p:sld xmlns:a="http://schemas.openxmlformats.org/drawingml/2006/main" xmlns:r="http://schemas.openxmlformats.org/officeDocument/2006/relationships" xmlns:p="http://schemas.openxmlformats.org/presentationml/2006/main">
+  <p:cSld>
+    <p:bg>
+      <p:bgPr>
+        <a:solidFill>
+          <a:srgbClr val="F8FAFC"/>
+        </a:solidFill>
+      </p:bgPr>
+    </p:bg>
+    <p:spTree>
+      <p:nvGrpSpPr>
+        <p:cNvPr id="1" name=""/>
+        <p:cNvGrpSpPr/>
+        <p:nvPr/>
+      </p:nvGrpSpPr>
+      <p:grpSpPr>
+        <a:xfrm>
+          <a:off x="0" y="0"/>
+          <a:ext cx="12192000" cy="6858000"/>
+          <a:chOff x="0" y="0"/>
+          <a:chExt cx="12192000" cy="6858000"/>
+        </a:xfrm>
+      </p:grpSpPr>
+      <p:sp>
+        <p:nvSpPr>
+          <p:cNvPr id="2" name="Text 2"/>
+          <p:cNvSpPr txBox="1"/>
+          <p:nvPr/>
+        </p:nvSpPr>
+        <p:spPr>
+          <a:xfrm>
+            <a:off x="502920" y="228600"/>
+            <a:ext cx="10972800" cy="256032"/>
+          </a:xfrm>
+          <a:prstGeom prst="rect">
+            <a:avLst/>
+          </a:prstGeom>
+          <a:noFill/>
+          <a:ln>
+            <a:noFill/>
+          </a:ln>
+        </p:spPr>
+        <p:txBody>
+          <a:bodyPr wrap="square" lIns="91440" tIns="45720" rIns="91440" bIns="45720"/>
+          <a:lstStyle/>
+          <a:p>
+            <a:r>
+              <a:rPr lang="vi-VN" sz="800" dirty="0">
+                <a:b/>
+                <a:solidFill>
+                  <a:srgbClr val="2563EB"/>
+                </a:solidFill>
+              </a:rPr>
               <a:t>CAVEATS</a:t>
             </a:r>
             <a:endParaRPr lang="vi-VN" sz="800"/>
@@ -1497,7 +1745,7 @@
                   <a:srgbClr val="14213D"/>
                 </a:solidFill>
               </a:rPr>
-              <a:t>Aspect summary rows: 7942</a:t>
+              <a:t>Aspect summary rows: 0</a:t>
             </a:r>
             <a:endParaRPr lang="vi-VN" sz="1250"/>
           </a:p>
@@ -1508,7 +1756,7 @@
                   <a:srgbClr val="14213D"/>
                 </a:solidFill>
               </a:rPr>
-              <a:t>Provenance rows: 7942</a:t>
+              <a:t>Provenance rows: 0</a:t>
             </a:r>
             <a:endParaRPr lang="vi-VN" sz="1250"/>
           </a:p>
@@ -1519,7 +1767,7 @@
                   <a:srgbClr val="14213D"/>
                 </a:solidFill>
               </a:rPr>
-              <a:t>Coverage: 1.0000</a:t>
+              <a:t>Coverage: 0.0000</a:t>
             </a:r>
             <a:endParaRPr lang="vi-VN" sz="1250"/>
           </a:p>
@@ -1569,29 +1817,7 @@
                   <a:srgbClr val="14213D"/>
                 </a:solidFill>
               </a:rPr>
-              <a:t>entity=100597 | aspect=FAC_ROOM | rank=1 | review=UR116685264</a:t>
-            </a:r>
-            <a:endParaRPr lang="vi-VN" sz="1000"/>
-          </a:p>
-          <a:p>
-            <a:r>
-              <a:rPr lang="vi-VN" sz="1000" dirty="0">
-                <a:solidFill>
-                  <a:srgbClr val="14213D"/>
-                </a:solidFill>
-              </a:rPr>
-              <a:t>seed=['room'] | sentiment=pos ['clean', 'comfortable']</a:t>
-            </a:r>
-            <a:endParaRPr lang="vi-VN" sz="1000"/>
-          </a:p>
-          <a:p>
-            <a:r>
-              <a:rPr lang="vi-VN" sz="1000" dirty="0">
-                <a:solidFill>
-                  <a:srgbClr val="14213D"/>
-                </a:solidFill>
-              </a:rPr>
-              <a:t>sentence: We had a balcony, the beds were super comfortable, room was a good size and clean.</a:t>
+              <a:t>Chưa có provenance sample. Rerun inference với trace_jsonl để sinh outputs/&lt;run_id&gt;_provenance.jsonl.</a:t>
             </a:r>
             <a:endParaRPr lang="vi-VN" sz="1000"/>
           </a:p>
@@ -2365,7 +2591,7 @@
                   <a:srgbClr val="2563EB"/>
                 </a:solidFill>
               </a:rPr>
-              <a:t>OUTPUT 1</a:t>
+              <a:t>OUTPUT CORRECTION</a:t>
             </a:r>
             <a:endParaRPr lang="vi-VN" sz="800"/>
           </a:p>
@@ -2401,7 +2627,7 @@
                   <a:srgbClr val="14213D"/>
                 </a:solidFill>
               </a:rPr>
-              <a:t>Top-5 ranked evidence dùng cho synthesis</a:t>
+              <a:t>Từ extractive sang abstractive</a:t>
             </a:r>
             <a:endParaRPr lang="vi-VN" sz="2300"/>
           </a:p>
@@ -2437,7 +2663,129 @@
         <p:spPr>
           <a:xfrm>
             <a:off x="685800" y="1234440"/>
-            <a:ext cx="2926080" cy="822960"/>
+            <a:ext cx="5029200" cy="1508760"/>
+          </a:xfrm>
+          <a:prstGeom prst="rect">
+            <a:avLst/>
+          </a:prstGeom>
+          <a:solidFill>
+            <a:srgbClr val="FFF7ED"/>
+          </a:solidFill>
+          <a:ln w="9525">
+            <a:solidFill>
+              <a:srgbClr val="FDBA74"/>
+            </a:solidFill>
+          </a:ln>
+        </p:spPr>
+        <p:txBody>
+          <a:bodyPr wrap="square" lIns="91440" tIns="45720" rIns="91440" bIns="45720"/>
+          <a:lstStyle/>
+          <a:p>
+            <a:r>
+              <a:rPr lang="vi-VN" sz="1200" dirty="0">
+                <a:solidFill>
+                  <a:srgbClr val="14213D"/>
+                </a:solidFill>
+              </a:rPr>
+              <a:t>Vấn đề bạn thấy là đúng</a:t>
+            </a:r>
+            <a:endParaRPr lang="vi-VN" sz="1200"/>
+          </a:p>
+          <a:p>
+            <a:r>
+              <a:rPr lang="vi-VN" sz="1200" dirty="0">
+                <a:solidFill>
+                  <a:srgbClr val="14213D"/>
+                </a:solidFill>
+              </a:rPr>
+              <a:t>Output SemAE gốc trong run này là extractive: chọn câu source rồi nối lại. Với max_tokens=40, câu cuối có thể bị cắt cụt như `Each room is named... and one of`.</a:t>
+            </a:r>
+            <a:endParaRPr lang="vi-VN" sz="1200"/>
+          </a:p>
+        </p:txBody>
+      </p:sp>
+      <p:sp>
+        <p:nvSpPr>
+          <p:cNvPr id="6" name="Text 6"/>
+          <p:cNvSpPr txBox="1"/>
+          <p:nvPr/>
+        </p:nvSpPr>
+        <p:spPr>
+          <a:xfrm>
+            <a:off x="5989320" y="1234440"/>
+            <a:ext cx="5074920" cy="1508760"/>
+          </a:xfrm>
+          <a:prstGeom prst="rect">
+            <a:avLst/>
+          </a:prstGeom>
+          <a:solidFill>
+            <a:srgbClr val="ECFDF5"/>
+          </a:solidFill>
+          <a:ln w="9525">
+            <a:solidFill>
+              <a:srgbClr val="99F6E4"/>
+            </a:solidFill>
+          </a:ln>
+        </p:spPr>
+        <p:txBody>
+          <a:bodyPr wrap="square" lIns="91440" tIns="45720" rIns="91440" bIns="45720"/>
+          <a:lstStyle/>
+          <a:p>
+            <a:r>
+              <a:rPr lang="vi-VN" sz="1200" dirty="0">
+                <a:solidFill>
+                  <a:srgbClr val="14213D"/>
+                </a:solidFill>
+              </a:rPr>
+              <a:t>Trạng thái artifact synthesis local</a:t>
+            </a:r>
+            <a:endParaRPr lang="vi-VN" sz="1200"/>
+          </a:p>
+          <a:p>
+            <a:r>
+              <a:rPr lang="vi-VN" sz="1200" dirty="0">
+                <a:solidFill>
+                  <a:srgbClr val="14213D"/>
+                </a:solidFill>
+              </a:rPr>
+              <a:t>Synthesis rows tìm thấy: 0</a:t>
+            </a:r>
+            <a:endParaRPr lang="vi-VN" sz="1200"/>
+          </a:p>
+          <a:p>
+            <a:r>
+              <a:rPr lang="vi-VN" sz="1200" dirty="0">
+                <a:solidFill>
+                  <a:srgbClr val="14213D"/>
+                </a:solidFill>
+              </a:rPr>
+              <a:t>Ranked evidence rows: 6850</a:t>
+            </a:r>
+            <a:endParaRPr lang="vi-VN" sz="1200"/>
+          </a:p>
+          <a:p>
+            <a:r>
+              <a:rPr lang="vi-VN" sz="1200" dirty="0">
+                <a:solidFill>
+                  <a:srgbClr val="14213D"/>
+                </a:solidFill>
+              </a:rPr>
+              <a:t>Deck sẽ không còn trình bày output extractive bị cắt như final summary.</a:t>
+            </a:r>
+            <a:endParaRPr lang="vi-VN" sz="1200"/>
+          </a:p>
+        </p:txBody>
+      </p:sp>
+      <p:sp>
+        <p:nvSpPr>
+          <p:cNvPr id="7" name="Text 7"/>
+          <p:cNvSpPr txBox="1"/>
+          <p:nvPr/>
+        </p:nvSpPr>
+        <p:spPr>
+          <a:xfrm>
+            <a:off x="685800" y="3246120"/>
+            <a:ext cx="10378440" cy="1325880"/>
           </a:xfrm>
           <a:prstGeom prst="rect">
             <a:avLst/>
@@ -2456,221 +2804,47 @@
           <a:lstStyle/>
           <a:p>
             <a:r>
-              <a:rPr lang="vi-VN" sz="1250" dirty="0">
-                <a:b/>
-                <a:solidFill>
-                  <a:srgbClr val="14213D"/>
-                </a:solidFill>
-              </a:rPr>
-              <a:t>Entity: 100585</a:t>
-            </a:r>
-            <a:endParaRPr lang="vi-VN" sz="1250"/>
-          </a:p>
-          <a:p>
-            <a:r>
-              <a:rPr lang="vi-VN" sz="1250" dirty="0">
-                <a:b/>
-                <a:solidFill>
-                  <a:srgbClr val="14213D"/>
-                </a:solidFill>
-              </a:rPr>
-              <a:t>Aspect: AM_ENT</a:t>
-            </a:r>
-            <a:endParaRPr lang="vi-VN" sz="1250"/>
-          </a:p>
-          <a:p>
-            <a:r>
-              <a:rPr lang="vi-VN" sz="1250" dirty="0">
-                <a:b/>
-                <a:solidFill>
-                  <a:srgbClr val="14213D"/>
-                </a:solidFill>
-              </a:rPr>
-              <a:t>Model: google/flan-t5-base</a:t>
-            </a:r>
-            <a:endParaRPr lang="vi-VN" sz="1250"/>
-          </a:p>
-        </p:txBody>
-      </p:sp>
-      <p:sp>
-        <p:nvSpPr>
-          <p:cNvPr id="6" name="Text 6"/>
-          <p:cNvSpPr txBox="1"/>
-          <p:nvPr/>
-        </p:nvSpPr>
-        <p:spPr>
-          <a:xfrm>
-            <a:off x="3794760" y="1234440"/>
-            <a:ext cx="7315200" cy="4389120"/>
-          </a:xfrm>
-          <a:prstGeom prst="rect">
-            <a:avLst/>
-          </a:prstGeom>
-          <a:solidFill>
-            <a:srgbClr val="FFFFFF"/>
-          </a:solidFill>
-          <a:ln w="9525">
-            <a:solidFill>
-              <a:srgbClr val="D8DEE9"/>
-            </a:solidFill>
-          </a:ln>
-        </p:spPr>
-        <p:txBody>
-          <a:bodyPr wrap="square" lIns="91440" tIns="45720" rIns="91440" bIns="45720"/>
-          <a:lstStyle/>
-          <a:p>
-            <a:r>
-              <a:rPr lang="vi-VN" sz="1050" dirty="0">
-                <a:solidFill>
-                  <a:srgbClr val="14213D"/>
-                </a:solidFill>
-              </a:rPr>
-              <a:t>1. rank=1 score=0.0009499341249465942</a:t>
-            </a:r>
-            <a:endParaRPr lang="vi-VN" sz="1050"/>
-          </a:p>
-          <a:p>
-            <a:r>
-              <a:rPr lang="vi-VN" sz="1050" dirty="0">
-                <a:solidFill>
-                  <a:srgbClr val="14213D"/>
-                </a:solidFill>
-              </a:rPr>
-              <a:t>I filled out one of their comment cards with a minor complaint (we found the tv system cumbersome) and I actualy received an e mail from the hotel management!</a:t>
-            </a:r>
-            <a:endParaRPr lang="vi-VN" sz="1050"/>
-          </a:p>
-          <a:p>
-            <a:r>
-              <a:rPr lang="vi-VN" sz="1050" dirty="0">
-                <a:solidFill>
-                  <a:srgbClr val="14213D"/>
-                </a:solidFill>
-              </a:rPr>
-              <a:t/>
-            </a:r>
-            <a:endParaRPr lang="vi-VN" sz="1050"/>
-          </a:p>
-          <a:p>
-            <a:r>
-              <a:rPr lang="vi-VN" sz="1050" dirty="0">
-                <a:solidFill>
-                  <a:srgbClr val="14213D"/>
-                </a:solidFill>
-              </a:rPr>
-              <a:t>2. rank=2 score=0.001678435131907463</a:t>
-            </a:r>
-            <a:endParaRPr lang="vi-VN" sz="1050"/>
-          </a:p>
-          <a:p>
-            <a:r>
-              <a:rPr lang="vi-VN" sz="1050" dirty="0">
-                <a:solidFill>
-                  <a:srgbClr val="14213D"/>
-                </a:solidFill>
-              </a:rPr>
-              <a:t>Each room is named after a Washington winery, and one of the hotel's TV channels broadcasts a WA wine country documentary 24/7.</a:t>
-            </a:r>
-            <a:endParaRPr lang="vi-VN" sz="1050"/>
-          </a:p>
-          <a:p>
-            <a:r>
-              <a:rPr lang="vi-VN" sz="1050" dirty="0">
-                <a:solidFill>
-                  <a:srgbClr val="14213D"/>
-                </a:solidFill>
-              </a:rPr>
-              <a:t/>
-            </a:r>
-            <a:endParaRPr lang="vi-VN" sz="1050"/>
-          </a:p>
-          <a:p>
-            <a:r>
-              <a:rPr lang="vi-VN" sz="1050" dirty="0">
-                <a:solidFill>
-                  <a:srgbClr val="14213D"/>
-                </a:solidFill>
-              </a:rPr>
-              <a:t>3. rank=3 score=0.0018258243799209595</a:t>
-            </a:r>
-            <a:endParaRPr lang="vi-VN" sz="1050"/>
-          </a:p>
-          <a:p>
-            <a:r>
-              <a:rPr lang="vi-VN" sz="1050" dirty="0">
-                <a:solidFill>
-                  <a:srgbClr val="14213D"/>
-                </a:solidFill>
-              </a:rPr>
-              <a:t>The little work out room is kind of a joke, but it is a clean and well appointed joke...the TV (w/headphones) on the exercise machines is nice.</a:t>
-            </a:r>
-            <a:endParaRPr lang="vi-VN" sz="1050"/>
-          </a:p>
-          <a:p>
-            <a:r>
-              <a:rPr lang="vi-VN" sz="1050" dirty="0">
-                <a:solidFill>
-                  <a:srgbClr val="14213D"/>
-                </a:solidFill>
-              </a:rPr>
-              <a:t/>
-            </a:r>
-            <a:endParaRPr lang="vi-VN" sz="1050"/>
-          </a:p>
-          <a:p>
-            <a:r>
-              <a:rPr lang="vi-VN" sz="1050" dirty="0">
-                <a:solidFill>
-                  <a:srgbClr val="14213D"/>
-                </a:solidFill>
-              </a:rPr>
-              <a:t>4. rank=4 score=0.0027439258992671967</a:t>
-            </a:r>
-            <a:endParaRPr lang="vi-VN" sz="1050"/>
-          </a:p>
-          <a:p>
-            <a:r>
-              <a:rPr lang="vi-VN" sz="1050" dirty="0">
-                <a:solidFill>
-                  <a:srgbClr val="14213D"/>
-                </a:solidFill>
-              </a:rPr>
-              <a:t>But there was in-room yoga on the TV and they gave me a yoga mat.</a:t>
-            </a:r>
-            <a:endParaRPr lang="vi-VN" sz="1050"/>
-          </a:p>
-          <a:p>
-            <a:r>
-              <a:rPr lang="vi-VN" sz="1050" dirty="0">
-                <a:solidFill>
-                  <a:srgbClr val="14213D"/>
-                </a:solidFill>
-              </a:rPr>
-              <a:t/>
-            </a:r>
-            <a:endParaRPr lang="vi-VN" sz="1050"/>
-          </a:p>
-          <a:p>
-            <a:r>
-              <a:rPr lang="vi-VN" sz="1050" dirty="0">
-                <a:solidFill>
-                  <a:srgbClr val="14213D"/>
-                </a:solidFill>
-              </a:rPr>
-              <a:t>5. rank=5 score=0.0034844130277633667</a:t>
-            </a:r>
-            <a:endParaRPr lang="vi-VN" sz="1050"/>
-          </a:p>
-          <a:p>
-            <a:r>
-              <a:rPr lang="vi-VN" sz="1050" dirty="0">
-                <a:solidFill>
-                  <a:srgbClr val="14213D"/>
-                </a:solidFill>
-              </a:rPr>
-              <a:t>While I do have some small quibbles with the property--there is no Fox News on the TV, it is very difficult to get into the on-site garage during peak traffic times, there is no view from the rooms, the lobb...</a:t>
-            </a:r>
-            <a:endParaRPr lang="vi-VN" sz="1050"/>
+              <a:rPr lang="vi-VN" sz="1180" dirty="0">
+                <a:solidFill>
+                  <a:srgbClr val="14213D"/>
+                </a:solidFill>
+              </a:rPr>
+              <a:t>Cách sửa chuẩn</a:t>
+            </a:r>
+            <a:endParaRPr lang="vi-VN" sz="1180"/>
+          </a:p>
+          <a:p>
+            <a:r>
+              <a:rPr lang="vi-VN" sz="1180" dirty="0">
+                <a:solidFill>
+                  <a:srgbClr val="14213D"/>
+                </a:solidFill>
+              </a:rPr>
+              <a:t>1. Rerun inference để sinh outputs/&lt;run_id&gt;_ranked_evidence.jsonl với full sentence trước truncate.</a:t>
+            </a:r>
+            <a:endParaRPr lang="vi-VN" sz="1180"/>
+          </a:p>
+          <a:p>
+            <a:r>
+              <a:rPr lang="vi-VN" sz="1180" dirty="0">
+                <a:solidFill>
+                  <a:srgbClr val="14213D"/>
+                </a:solidFill>
+              </a:rPr>
+              <a:t>2. Run synthesize_aspect_summaries.py --source_mode ranked_evidence.</a:t>
+            </a:r>
+            <a:endParaRPr lang="vi-VN" sz="1180"/>
+          </a:p>
+          <a:p>
+            <a:r>
+              <a:rPr lang="vi-VN" sz="1180" dirty="0">
+                <a:solidFill>
+                  <a:srgbClr val="14213D"/>
+                </a:solidFill>
+              </a:rPr>
+              <a:t>3. Build lại deck; slide output sẽ lấy abstractive summary đã lọc prompt echo/hallucination.</a:t>
+            </a:r>
+            <a:endParaRPr lang="vi-VN" sz="1180"/>
           </a:p>
         </p:txBody>
       </p:sp>
@@ -2736,7 +2910,7 @@
                   <a:srgbClr val="2563EB"/>
                 </a:solidFill>
               </a:rPr>
-              <a:t>OUTPUT 2</a:t>
+              <a:t>OUTPUT</a:t>
             </a:r>
             <a:endParaRPr lang="vi-VN" sz="800"/>
           </a:p>
@@ -2772,7 +2946,7 @@
                   <a:srgbClr val="14213D"/>
                 </a:solidFill>
               </a:rPr>
-              <a:t>FLAN/T5 abstractive summary từ ranked evidence</a:t>
+              <a:t>Top-5 evidence + FLAN-T5 output</a:t>
             </a:r>
             <a:endParaRPr lang="vi-VN" sz="2300"/>
           </a:p>
@@ -2807,8 +2981,8 @@
         </p:nvSpPr>
         <p:spPr>
           <a:xfrm>
-            <a:off x="685800" y="1234440"/>
-            <a:ext cx="10515600" cy="4572000"/>
+            <a:off x="685800" y="1143000"/>
+            <a:ext cx="2880360" cy="868680"/>
           </a:xfrm>
           <a:prstGeom prst="rect">
             <a:avLst/>
@@ -2827,14 +3001,282 @@
           <a:lstStyle/>
           <a:p>
             <a:r>
-              <a:rPr lang="vi-VN" sz="1050" dirty="0">
-                <a:solidFill>
-                  <a:srgbClr val="14213D"/>
-                </a:solidFill>
-              </a:rPr>
-              <a:t>The hotel is a great place to relax and have a good time.</a:t>
-            </a:r>
-            <a:endParaRPr lang="vi-VN" sz="1050"/>
+              <a:rPr lang="vi-VN" sz="1150" dirty="0">
+                <a:b/>
+                <a:solidFill>
+                  <a:srgbClr val="14213D"/>
+                </a:solidFill>
+              </a:rPr>
+              <a:t>Entity: 100585</a:t>
+            </a:r>
+            <a:endParaRPr lang="vi-VN" sz="1150"/>
+          </a:p>
+          <a:p>
+            <a:r>
+              <a:rPr lang="vi-VN" sz="1150" dirty="0">
+                <a:b/>
+                <a:solidFill>
+                  <a:srgbClr val="14213D"/>
+                </a:solidFill>
+              </a:rPr>
+              <a:t>Aspect: FAC_ROOM</a:t>
+            </a:r>
+            <a:endParaRPr lang="vi-VN" sz="1150"/>
+          </a:p>
+          <a:p>
+            <a:r>
+              <a:rPr lang="vi-VN" sz="1150" dirty="0">
+                <a:b/>
+                <a:solidFill>
+                  <a:srgbClr val="14213D"/>
+                </a:solidFill>
+              </a:rPr>
+              <a:t>Model: google/flan-t5-base</a:t>
+            </a:r>
+            <a:endParaRPr lang="vi-VN" sz="1150"/>
+          </a:p>
+        </p:txBody>
+      </p:sp>
+      <p:sp>
+        <p:nvSpPr>
+          <p:cNvPr id="6" name="Text 6"/>
+          <p:cNvSpPr txBox="1"/>
+          <p:nvPr/>
+        </p:nvSpPr>
+        <p:spPr>
+          <a:xfrm>
+            <a:off x="3794760" y="1143000"/>
+            <a:ext cx="7315200" cy="2880360"/>
+          </a:xfrm>
+          <a:prstGeom prst="rect">
+            <a:avLst/>
+          </a:prstGeom>
+          <a:solidFill>
+            <a:srgbClr val="FFFFFF"/>
+          </a:solidFill>
+          <a:ln w="9525">
+            <a:solidFill>
+              <a:srgbClr val="D8DEE9"/>
+            </a:solidFill>
+          </a:ln>
+        </p:spPr>
+        <p:txBody>
+          <a:bodyPr wrap="square" lIns="91440" tIns="45720" rIns="91440" bIns="45720"/>
+          <a:lstStyle/>
+          <a:p>
+            <a:r>
+              <a:rPr lang="vi-VN" sz="720" dirty="0">
+                <a:solidFill>
+                  <a:srgbClr val="14213D"/>
+                </a:solidFill>
+              </a:rPr>
+              <a:t>Top-5 evidence used as source</a:t>
+            </a:r>
+            <a:endParaRPr lang="vi-VN" sz="720"/>
+          </a:p>
+          <a:p>
+            <a:r>
+              <a:rPr lang="vi-VN" sz="720" dirty="0">
+                <a:solidFill>
+                  <a:srgbClr val="14213D"/>
+                </a:solidFill>
+              </a:rPr>
+              <a:t>1. rank=1 score=0.004206815734505653</a:t>
+            </a:r>
+            <a:endParaRPr lang="vi-VN" sz="720"/>
+          </a:p>
+          <a:p>
+            <a:r>
+              <a:rPr lang="vi-VN" sz="720" dirty="0">
+                <a:solidFill>
+                  <a:srgbClr val="14213D"/>
+                </a:solidFill>
+              </a:rPr>
+              <a:t>The minus was for the slightly worn out chair in the room, a bath towel that had seen better days, and the rather high parking rate - $30/night.</a:t>
+            </a:r>
+            <a:endParaRPr lang="vi-VN" sz="720"/>
+          </a:p>
+          <a:p>
+            <a:r>
+              <a:rPr lang="vi-VN" sz="720" dirty="0">
+                <a:solidFill>
+                  <a:srgbClr val="14213D"/>
+                </a:solidFill>
+              </a:rPr>
+              <a:t/>
+            </a:r>
+            <a:endParaRPr lang="vi-VN" sz="720"/>
+          </a:p>
+          <a:p>
+            <a:r>
+              <a:rPr lang="vi-VN" sz="720" dirty="0">
+                <a:solidFill>
+                  <a:srgbClr val="14213D"/>
+                </a:solidFill>
+              </a:rPr>
+              <a:t>2. rank=2 score=0.004822632297873497</a:t>
+            </a:r>
+            <a:endParaRPr lang="vi-VN" sz="720"/>
+          </a:p>
+          <a:p>
+            <a:r>
+              <a:rPr lang="vi-VN" sz="720" dirty="0">
+                <a:solidFill>
+                  <a:srgbClr val="14213D"/>
+                </a:solidFill>
+              </a:rPr>
+              <a:t>The first night my room overlooked a parking lot, and even though it was a fifth floor room, it felt like I was looking into the headlights.</a:t>
+            </a:r>
+            <a:endParaRPr lang="vi-VN" sz="720"/>
+          </a:p>
+          <a:p>
+            <a:r>
+              <a:rPr lang="vi-VN" sz="720" dirty="0">
+                <a:solidFill>
+                  <a:srgbClr val="14213D"/>
+                </a:solidFill>
+              </a:rPr>
+              <a:t/>
+            </a:r>
+            <a:endParaRPr lang="vi-VN" sz="720"/>
+          </a:p>
+          <a:p>
+            <a:r>
+              <a:rPr lang="vi-VN" sz="720" dirty="0">
+                <a:solidFill>
+                  <a:srgbClr val="14213D"/>
+                </a:solidFill>
+              </a:rPr>
+              <a:t>3. rank=3 score=0.005135664716362953</a:t>
+            </a:r>
+            <a:endParaRPr lang="vi-VN" sz="720"/>
+          </a:p>
+          <a:p>
+            <a:r>
+              <a:rPr lang="vi-VN" sz="720" dirty="0">
+                <a:solidFill>
+                  <a:srgbClr val="14213D"/>
+                </a:solidFill>
+              </a:rPr>
+              <a:t>The room was well appointed, with an excellent mini bar, soft robes, slipper socks for chilly feet (purchase), and quality toiletry items.</a:t>
+            </a:r>
+            <a:endParaRPr lang="vi-VN" sz="720"/>
+          </a:p>
+          <a:p>
+            <a:r>
+              <a:rPr lang="vi-VN" sz="720" dirty="0">
+                <a:solidFill>
+                  <a:srgbClr val="14213D"/>
+                </a:solidFill>
+              </a:rPr>
+              <a:t/>
+            </a:r>
+            <a:endParaRPr lang="vi-VN" sz="720"/>
+          </a:p>
+          <a:p>
+            <a:r>
+              <a:rPr lang="vi-VN" sz="720" dirty="0">
+                <a:solidFill>
+                  <a:srgbClr val="14213D"/>
+                </a:solidFill>
+              </a:rPr>
+              <a:t>4. rank=4 score=0.005199769511818886</a:t>
+            </a:r>
+            <a:endParaRPr lang="vi-VN" sz="720"/>
+          </a:p>
+          <a:p>
+            <a:r>
+              <a:rPr lang="vi-VN" sz="720" dirty="0">
+                <a:solidFill>
+                  <a:srgbClr val="14213D"/>
+                </a:solidFill>
+              </a:rPr>
+              <a:t>Although the bed was comfortable, it was noisy and squeaky for two, and we needed an extra blanket.</a:t>
+            </a:r>
+            <a:endParaRPr lang="vi-VN" sz="720"/>
+          </a:p>
+          <a:p>
+            <a:r>
+              <a:rPr lang="vi-VN" sz="720" dirty="0">
+                <a:solidFill>
+                  <a:srgbClr val="14213D"/>
+                </a:solidFill>
+              </a:rPr>
+              <a:t/>
+            </a:r>
+            <a:endParaRPr lang="vi-VN" sz="720"/>
+          </a:p>
+          <a:p>
+            <a:r>
+              <a:rPr lang="vi-VN" sz="720" dirty="0">
+                <a:solidFill>
+                  <a:srgbClr val="14213D"/>
+                </a:solidFill>
+              </a:rPr>
+              <a:t>5. rank=5 score=0.005245797336101532</a:t>
+            </a:r>
+            <a:endParaRPr lang="vi-VN" sz="720"/>
+          </a:p>
+          <a:p>
+            <a:r>
+              <a:rPr lang="vi-VN" sz="720" dirty="0">
+                <a:solidFill>
+                  <a:srgbClr val="14213D"/>
+                </a:solidFill>
+              </a:rPr>
+              <a:t>The room and the bathroom we had, were quite small and dark, with an uninteresting view from the window.</a:t>
+            </a:r>
+            <a:endParaRPr lang="vi-VN" sz="720"/>
+          </a:p>
+        </p:txBody>
+      </p:sp>
+      <p:sp>
+        <p:nvSpPr>
+          <p:cNvPr id="7" name="Text 7"/>
+          <p:cNvSpPr txBox="1"/>
+          <p:nvPr/>
+        </p:nvSpPr>
+        <p:spPr>
+          <a:xfrm>
+            <a:off x="685800" y="4251960"/>
+            <a:ext cx="10424160" cy="960120"/>
+          </a:xfrm>
+          <a:prstGeom prst="rect">
+            <a:avLst/>
+          </a:prstGeom>
+          <a:solidFill>
+            <a:srgbClr val="ECFDF5"/>
+          </a:solidFill>
+          <a:ln w="9525">
+            <a:solidFill>
+              <a:srgbClr val="99F6E4"/>
+            </a:solidFill>
+          </a:ln>
+        </p:spPr>
+        <p:txBody>
+          <a:bodyPr wrap="square" lIns="91440" tIns="45720" rIns="91440" bIns="45720"/>
+          <a:lstStyle/>
+          <a:p>
+            <a:r>
+              <a:rPr lang="vi-VN" sz="980" dirty="0">
+                <a:solidFill>
+                  <a:srgbClr val="14213D"/>
+                </a:solidFill>
+              </a:rPr>
+              <a:t>FLAN-T5 output</a:t>
+            </a:r>
+            <a:endParaRPr lang="vi-VN" sz="980"/>
+          </a:p>
+          <a:p>
+            <a:r>
+              <a:rPr lang="vi-VN" sz="980" dirty="0">
+                <a:solidFill>
+                  <a:srgbClr val="14213D"/>
+                </a:solidFill>
+              </a:rPr>
+              <a:t>Room, Bed &amp; Sleep Quality (FAC_ROOM): The room was well appointed, with an excellent mini bar, soft robes, slipper socks for chilly feet (purchase), and quality toiletry items. The first night my room overlooked a parking lot, and even though it was a fifth floor room, it felt like I was looking into the headlights</a:t>
+            </a:r>
+            <a:endParaRPr lang="vi-VN" sz="980"/>
           </a:p>
         </p:txBody>
       </p:sp>
@@ -2900,7 +3342,7 @@
                   <a:srgbClr val="2563EB"/>
                 </a:solidFill>
               </a:rPr>
-              <a:t>QUALITY</a:t>
+              <a:t>OUTPUT DETAIL</a:t>
             </a:r>
             <a:endParaRPr lang="vi-VN" sz="800"/>
           </a:p>
@@ -2936,7 +3378,7 @@
                   <a:srgbClr val="14213D"/>
                 </a:solidFill>
               </a:rPr>
-              <a:t>Metrics và health checks</a:t>
+              <a:t>Evidence đa aspect + top-5 nghĩa là gì</a:t>
             </a:r>
             <a:endParaRPr lang="vi-VN" sz="2300"/>
           </a:p>
@@ -2971,8 +3413,8 @@
         </p:nvSpPr>
         <p:spPr>
           <a:xfrm>
-            <a:off x="777240" y="1325880"/>
-            <a:ext cx="4709160" cy="2057400"/>
+            <a:off x="685800" y="1143000"/>
+            <a:ext cx="6400800" cy="4709160"/>
           </a:xfrm>
           <a:prstGeom prst="rect">
             <a:avLst/>
@@ -2991,58 +3433,14 @@
           <a:lstStyle/>
           <a:p>
             <a:r>
-              <a:rPr lang="vi-VN" sz="1250" dirty="0">
-                <a:solidFill>
-                  <a:srgbClr val="14213D"/>
-                </a:solidFill>
-              </a:rPr>
-              <a:t>source_fidelity: n/a</a:t>
-            </a:r>
-            <a:endParaRPr lang="vi-VN" sz="1250"/>
-          </a:p>
-          <a:p>
-            <a:r>
-              <a:rPr lang="vi-VN" sz="1250" dirty="0">
-                <a:solidFill>
-                  <a:srgbClr val="14213D"/>
-                </a:solidFill>
-              </a:rPr>
-              <a:t>source_fidelity_excl_truncated: n/a</a:t>
-            </a:r>
-            <a:endParaRPr lang="vi-VN" sz="1250"/>
-          </a:p>
-          <a:p>
-            <a:r>
-              <a:rPr lang="vi-VN" sz="1250" dirty="0">
-                <a:solidFill>
-                  <a:srgbClr val="14213D"/>
-                </a:solidFill>
-              </a:rPr>
-              <a:t>aspect_purity: n/a</a:t>
-            </a:r>
-            <a:endParaRPr lang="vi-VN" sz="1250"/>
-          </a:p>
-          <a:p>
-            <a:r>
-              <a:rPr lang="vi-VN" sz="1250" dirty="0">
-                <a:solidFill>
-                  <a:srgbClr val="14213D"/>
-                </a:solidFill>
-              </a:rPr>
-              <a:t>distinct_2: n/a</a:t>
-            </a:r>
-            <a:endParaRPr lang="vi-VN" sz="1250"/>
-          </a:p>
-          <a:p>
-            <a:r>
-              <a:rPr lang="vi-VN" sz="1250" dirty="0">
-                <a:solidFill>
-                  <a:srgbClr val="14213D"/>
-                </a:solidFill>
-              </a:rPr>
-              <a:t>self_bleu4: n/a</a:t>
-            </a:r>
-            <a:endParaRPr lang="vi-VN" sz="1250"/>
+              <a:rPr lang="vi-VN" sz="780" dirty="0">
+                <a:solidFill>
+                  <a:srgbClr val="14213D"/>
+                </a:solidFill>
+              </a:rPr>
+              <a:t>Không tìm thấy aspect evidence examples.</a:t>
+            </a:r>
+            <a:endParaRPr lang="vi-VN" sz="780"/>
           </a:p>
         </p:txBody>
       </p:sp>
@@ -3054,34 +3452,128 @@
         </p:nvSpPr>
         <p:spPr>
           <a:xfrm>
-            <a:off x="5577840" y="1325880"/>
-            <a:ext cx="5486400" cy="1143000"/>
+            <a:off x="7315200" y="1143000"/>
+            <a:ext cx="3886200" cy="2057400"/>
           </a:xfrm>
           <a:prstGeom prst="rect">
             <a:avLst/>
           </a:prstGeom>
           <a:solidFill>
-            <a:srgbClr val="FFFFFF"/>
+            <a:srgbClr val="FFF7ED"/>
           </a:solidFill>
           <a:ln w="9525">
             <a:solidFill>
-              <a:srgbClr val="D8DEE9"/>
-            </a:solidFill>
-          </a:ln>
-        </p:spPr>
-        <p:txBody>
-          <a:bodyPr wrap="square" lIns="91440" tIns="45720" rIns="91440" bIns="45720"/>
-          <a:lstStyle/>
-          <a:p>
-            <a:r>
-              <a:rPr lang="vi-VN" sz="1250" dirty="0">
-                <a:solidFill>
-                  <a:srgbClr val="14213D"/>
-                </a:solidFill>
-              </a:rPr>
-              <a:t>HASOS không có gold summary nên dùng reference-free metrics: fidelity, purity, diversity, compression. BERTScore có thể chạy thêm nếu dependency/model tải được.</a:t>
-            </a:r>
-            <a:endParaRPr lang="vi-VN" sz="1250"/>
+              <a:srgbClr val="FDBA74"/>
+            </a:solidFill>
+          </a:ln>
+        </p:spPr>
+        <p:txBody>
+          <a:bodyPr wrap="square" lIns="91440" tIns="45720" rIns="91440" bIns="45720"/>
+          <a:lstStyle/>
+          <a:p>
+            <a:r>
+              <a:rPr lang="vi-VN" sz="930" dirty="0">
+                <a:solidFill>
+                  <a:srgbClr val="14213D"/>
+                </a:solidFill>
+              </a:rPr>
+              <a:t>Top-5 đang nói tới gì?</a:t>
+            </a:r>
+            <a:endParaRPr lang="vi-VN" sz="930"/>
+          </a:p>
+          <a:p>
+            <a:r>
+              <a:rPr lang="vi-VN" sz="930" dirty="0">
+                <a:solidFill>
+                  <a:srgbClr val="14213D"/>
+                </a:solidFill>
+              </a:rPr>
+              <a:t>- Top-5 = tối đa 5 evidence sentences cho mỗi cặp entity/aspect.</a:t>
+            </a:r>
+            <a:endParaRPr lang="vi-VN" sz="930"/>
+          </a:p>
+          <a:p>
+            <a:r>
+              <a:rPr lang="vi-VN" sz="930" dirty="0">
+                <a:solidFill>
+                  <a:srgbClr val="14213D"/>
+                </a:solidFill>
+              </a:rPr>
+              <a:t>- Không phải top 5 aspect.</a:t>
+            </a:r>
+            <a:endParaRPr lang="vi-VN" sz="930"/>
+          </a:p>
+          <a:p>
+            <a:r>
+              <a:rPr lang="vi-VN" sz="930" dirty="0">
+                <a:solidFill>
+                  <a:srgbClr val="14213D"/>
+                </a:solidFill>
+              </a:rPr>
+              <a:t>- Slide trước chỉ hiện 1 sample vì deck đang lấy first synthesis row hợp lệ.</a:t>
+            </a:r>
+            <a:endParaRPr lang="vi-VN" sz="930"/>
+          </a:p>
+          <a:p>
+            <a:r>
+              <a:rPr lang="vi-VN" sz="930" dirty="0">
+                <a:solidFill>
+                  <a:srgbClr val="14213D"/>
+                </a:solidFill>
+              </a:rPr>
+              <a:t>- Máy local hiện không có ranked_evidence full; chỉ còn artifact test cũ của AM_ENT.</a:t>
+            </a:r>
+            <a:endParaRPr lang="vi-VN" sz="930"/>
+          </a:p>
+        </p:txBody>
+      </p:sp>
+      <p:sp>
+        <p:nvSpPr>
+          <p:cNvPr id="7" name="Text 7"/>
+          <p:cNvSpPr txBox="1"/>
+          <p:nvPr/>
+        </p:nvSpPr>
+        <p:spPr>
+          <a:xfrm>
+            <a:off x="7315200" y="3520440"/>
+            <a:ext cx="3886200" cy="1234440"/>
+          </a:xfrm>
+          <a:prstGeom prst="rect">
+            <a:avLst/>
+          </a:prstGeom>
+          <a:solidFill>
+            <a:srgbClr val="EEF6FF"/>
+          </a:solidFill>
+          <a:ln w="9525">
+            <a:solidFill>
+              <a:srgbClr val="BFDBFE"/>
+            </a:solidFill>
+          </a:ln>
+        </p:spPr>
+        <p:txBody>
+          <a:bodyPr wrap="square" lIns="91440" tIns="45720" rIns="91440" bIns="45720"/>
+          <a:lstStyle/>
+          <a:p>
+            <a:r>
+              <a:rPr lang="vi-VN" sz="860" dirty="0">
+                <a:solidFill>
+                  <a:srgbClr val="14213D"/>
+                </a:solidFill>
+              </a:rPr>
+              <a:t>Cách đọc slide</a:t>
+            </a:r>
+            <a:endParaRPr lang="vi-VN" sz="860"/>
+          </a:p>
+          <a:p>
+            <a:r>
+              <a:rPr lang="vi-VN" sz="860" dirty="0">
+                <a:solidFill>
+                  <a:srgbClr val="14213D"/>
+                </a:solidFill>
+              </a:rPr>
+              <a:t>Bên trái là nhiều aspect khác nhau từ extractive evidence. Nó giúp thấy coverage theo aspect. Output synthesis đầy đủ cần artifact ranked_evidence/synthesis full; nếu artifact đó chưa ở local thì deck không thể tự dựng đủ top-5 synthesis.</a:t>
+            </a:r>
+            <a:endParaRPr lang="vi-VN" sz="860"/>
           </a:p>
         </p:txBody>
       </p:sp>

</xml_diff>